<commit_message>
fix(centaurus): McKinsey button colors, HAIEC brief section, remove em dashes and audience facts
</commit_message>
<xml_diff>
--- a/public/centaurus/haiec-technical-architecture-defensibility-brief.pptx
+++ b/public/centaurus/haiec-technical-architecture-defensibility-brief.pptx
@@ -2998,7 +2998,7 @@
                 <a:ea typeface="Arial" pitchFamily="34" charset="-122"/>
                 <a:cs typeface="Arial" pitchFamily="34" charset="-120"/>
               </a:rPr>
-              <a:t>•  17 files in lib/compliance-twin/ — entirely TypeScript</a:t>
+              <a:t>•  17 files in lib/compliance-twin/ - entirely TypeScript</a:t>
             </a:r>
             <a:endParaRPr lang="en-US" sz="800" dirty="0"/>
           </a:p>
@@ -5460,7 +5460,7 @@
                 <a:ea typeface="Arial" pitchFamily="34" charset="-122"/>
                 <a:cs typeface="Arial" pitchFamily="34" charset="-120"/>
               </a:rPr>
-              <a:t>More systems tested can improve attack coverage, remediation patterns and framework mappings — subject to privacy, tenancy and data-use constraints.</a:t>
+              <a:t>More systems tested can improve attack coverage, remediation patterns and framework mappings - subject to privacy, tenancy and data-use constraints.</a:t>
             </a:r>
             <a:endParaRPr lang="en-US" sz="900" dirty="0"/>
           </a:p>
@@ -5628,7 +5628,7 @@
                 <a:ea typeface="Arial" pitchFamily="34" charset="-122"/>
                 <a:cs typeface="Arial" pitchFamily="34" charset="-120"/>
               </a:rPr>
-              <a:t>Each layer reinforces the next. The evidence relationship — not any single scanner — is the defensible asset.</a:t>
+              <a:t>Each layer reinforces the next. The evidence relationship - not any single scanner - is the defensible asset.</a:t>
             </a:r>
             <a:endParaRPr lang="en-US" sz="1100" dirty="0"/>
           </a:p>
@@ -9250,7 +9250,7 @@
                 <a:ea typeface="Arial" pitchFamily="34" charset="-122"/>
                 <a:cs typeface="Arial" pitchFamily="34" charset="-120"/>
               </a:rPr>
-              <a:t>Generated: 2026-07-31  ·  Source commit: d0298e7</a:t>
+              <a:t>Generated: 2026-07-31  ·  Source commit: 70b7399</a:t>
             </a:r>
             <a:endParaRPr lang="en-US" sz="800" dirty="0"/>
           </a:p>
@@ -13976,7 +13976,7 @@
                 <a:ea typeface="Arial" pitchFamily="34" charset="-122"/>
                 <a:cs typeface="Arial" pitchFamily="34" charset="-120"/>
               </a:rPr>
-              <a:t>HAIEC closes this gap by making evidence the central artifact — not a byproduct.</a:t>
+              <a:t>HAIEC closes this gap by making evidence the central artifact - not a byproduct.</a:t>
             </a:r>
             <a:endParaRPr lang="en-US" sz="1300" dirty="0"/>
           </a:p>
@@ -20298,7 +20298,7 @@
                 <a:ea typeface="Arial" pitchFamily="34" charset="-122"/>
                 <a:cs typeface="Arial" pitchFamily="34" charset="-120"/>
               </a:rPr>
-              <a:t>Maturity: Static engine — Implemented. Runtime engine — Active development with full execution path operational.</a:t>
+              <a:t>Maturity: Static engine - Implemented. Runtime engine - Active development with full execution path operational.</a:t>
             </a:r>
             <a:endParaRPr lang="en-US" sz="900" dirty="0"/>
           </a:p>
@@ -21435,7 +21435,7 @@
                 <a:ea typeface="Arial" pitchFamily="34" charset="-122"/>
                 <a:cs typeface="Arial" pitchFamily="34" charset="-120"/>
               </a:rPr>
-              <a:t>Every evidence record binds a finding to its source, its scope, its engine version, and its compliance mapping — at the point of generation.</a:t>
+              <a:t>Every evidence record binds a finding to its source, its scope, its engine version, and its compliance mapping - at the point of generation.</a:t>
             </a:r>
             <a:endParaRPr lang="en-US" sz="1200" dirty="0"/>
           </a:p>
@@ -22034,7 +22034,7 @@
                 <a:ea typeface="Arial" pitchFamily="34" charset="-122"/>
                 <a:cs typeface="Arial" pitchFamily="34" charset="-120"/>
               </a:rPr>
-              <a:t>Maturity: Evidence integrity — Implemented. HMAC-SHA256 with key rotation and replay protection. Upgrade path: Ed25519 public-key signatures for independent verification.</a:t>
+              <a:t>Maturity: Evidence integrity - Implemented. HMAC-SHA256 with key rotation and replay protection. Upgrade path: Ed25519 public-key signatures for independent verification.</a:t>
             </a:r>
             <a:endParaRPr lang="en-US" sz="800" dirty="0"/>
           </a:p>
@@ -23423,7 +23423,7 @@
                 <a:ea typeface="Arial" pitchFamily="34" charset="-122"/>
                 <a:cs typeface="Arial" pitchFamily="34" charset="-120"/>
               </a:rPr>
-              <a:t>A single remediation can generate reusable technical evidence across multiple assurance reviews. The same source change, retest and evidence record can support related OWASP, NIST, SOC 2, ISO and EU AI Act control evaluations — without recollecting the technical evidence separately for each framework.</a:t>
+              <a:t>A single remediation can generate reusable technical evidence across multiple assurance reviews. The same source change, retest and evidence record can support related OWASP, NIST, SOC 2, ISO and EU AI Act control evaluations - without recollecting the technical evidence separately for each framework.</a:t>
             </a:r>
             <a:endParaRPr lang="en-US" sz="1000" dirty="0"/>
           </a:p>
@@ -23507,7 +23507,7 @@
                 <a:ea typeface="Arial" pitchFamily="34" charset="-122"/>
                 <a:cs typeface="Arial" pitchFamily="34" charset="-120"/>
               </a:rPr>
-              <a:t>Source: lib/ai-security/compliance-mappings.ts — 82 unique rule IDs mapped to 13 compliance frameworks.</a:t>
+              <a:t>Source: lib/ai-security/compliance-mappings.ts - 82 unique rule IDs mapped to 13 compliance frameworks.</a:t>
             </a:r>
             <a:endParaRPr lang="en-US" sz="800" dirty="0"/>
           </a:p>
@@ -24186,7 +24186,7 @@
                 <a:ea typeface="Arial" pitchFamily="34" charset="-122"/>
                 <a:cs typeface="Arial" pitchFamily="34" charset="-120"/>
               </a:rPr>
-              <a:t>Decision Integrity Score (DIS) = weighted average × coverage penalty</a:t>
+              <a:t>Decision Integrity Score (DIS) = weighted average �- coverage penalty</a:t>
             </a:r>
             <a:endParaRPr lang="en-US" sz="900" dirty="0"/>
           </a:p>
@@ -24728,7 +24728,7 @@
                 <a:ea typeface="Arial" pitchFamily="34" charset="-122"/>
                 <a:cs typeface="Arial" pitchFamily="34" charset="-120"/>
               </a:rPr>
-              <a:t>•  Coverage penalty: &lt;50% → ×0.85, 50-74% → ×0.95, ≥75% → ×1.00</a:t>
+              <a:t>•  Coverage penalty: &lt;50% → �-0.85, 50-74% → �-0.95, ≥75% → �-1.00</a:t>
             </a:r>
             <a:endParaRPr lang="en-US" sz="800" dirty="0"/>
           </a:p>
@@ -25302,7 +25302,7 @@
                 <a:ea typeface="Arial" pitchFamily="34" charset="-122"/>
                 <a:cs typeface="Arial" pitchFamily="34" charset="-120"/>
               </a:rPr>
-              <a:t>Product principle: UI never computes scores — it only reads from aggregation output tables. Methodology version is locked at compute time.</a:t>
+              <a:t>Product principle: UI never computes scores - it only reads from aggregation output tables. Methodology version is locked at compute time.</a:t>
             </a:r>
             <a:endParaRPr lang="en-US" sz="1000" dirty="0"/>
           </a:p>
@@ -25344,7 +25344,7 @@
                 <a:ea typeface="Arial" pitchFamily="34" charset="-122"/>
                 <a:cs typeface="Arial" pitchFamily="34" charset="-120"/>
               </a:rPr>
-              <a:t>Maturity: Decision Pipeline — Implemented (scoring, aggregation, audit package, PARTIAL_RUN exclusion). Findings-level blocker enforcement in active development for eligibility gate activation.</a:t>
+              <a:t>Maturity: Decision Pipeline - Implemented (scoring, aggregation, audit package, PARTIAL_RUN exclusion). Findings-level blocker enforcement in active development for eligibility gate activation.</a:t>
             </a:r>
             <a:endParaRPr lang="en-US" sz="900" dirty="0"/>
           </a:p>

</xml_diff>